<commit_message>
update TOC slide with new outline structure
Agent-Logs-Url: https://github.com/Takumin321/kaadai/sessions/a4dbadcc-4862-4223-bd76-24c6452fed67

Co-authored-by: Takumin321 <186550280+Takumin321@users.noreply.github.com>
</commit_message>
<xml_diff>
--- a/resnet_presentation.pptx
+++ b/resnet_presentation.pptx
@@ -3861,123 +3861,102 @@
           </a:bodyPr>
           <a:lstStyle/>
           <a:p>
-            <a:pPr>
-              <a:spcBef>
-                <a:spcPts val="600"/>
-              </a:spcBef>
-            </a:pPr>
-            <a:r>
-              <a:rPr sz="1900" b="1">
-                <a:solidFill>
-                  <a:srgbClr val="1A3A6C"/>
-                </a:solidFill>
-              </a:rPr>
-              <a:t>• 研究背景と動機</a:t>
-            </a:r>
-          </a:p>
-          <a:p>
-            <a:pPr>
-              <a:spcBef>
-                <a:spcPts val="600"/>
-              </a:spcBef>
-            </a:pPr>
-            <a:r>
-              <a:rPr sz="1900" b="1">
-                <a:solidFill>
-                  <a:srgbClr val="1A3A6C"/>
-                </a:solidFill>
-              </a:rPr>
-              <a:t>• 問題提起：深いネットワークの劣化問題</a:t>
-            </a:r>
-          </a:p>
-          <a:p>
-            <a:pPr>
-              <a:spcBef>
-                <a:spcPts val="600"/>
-              </a:spcBef>
-            </a:pPr>
-            <a:r>
-              <a:rPr sz="1900" b="1">
-                <a:solidFill>
-                  <a:srgbClr val="1A3A6C"/>
-                </a:solidFill>
-              </a:rPr>
-              <a:t>• 提案手法：Residual Learning</a:t>
-            </a:r>
-          </a:p>
-          <a:p>
-            <a:pPr>
-              <a:spcBef>
-                <a:spcPts val="600"/>
-              </a:spcBef>
-            </a:pPr>
-            <a:r>
-              <a:rPr sz="1900" b="1">
-                <a:solidFill>
-                  <a:srgbClr val="1A3A6C"/>
-                </a:solidFill>
-              </a:rPr>
-              <a:t>• ネットワークアーキテクチャ（ResNet）</a:t>
-            </a:r>
-          </a:p>
-          <a:p>
-            <a:pPr>
-              <a:spcBef>
-                <a:spcPts val="600"/>
-              </a:spcBef>
-            </a:pPr>
-            <a:r>
-              <a:rPr sz="1900" b="1">
-                <a:solidFill>
-                  <a:srgbClr val="1A3A6C"/>
-                </a:solidFill>
-              </a:rPr>
-              <a:t>• 実験結果</a:t>
-            </a:r>
-          </a:p>
-          <a:p>
-            <a:pPr lvl="1">
-              <a:spcBef>
-                <a:spcPts val="200"/>
-              </a:spcBef>
-            </a:pPr>
-            <a:r>
-              <a:rPr sz="1600" b="0">
-                <a:solidFill>
-                  <a:srgbClr val="2D3748"/>
-                </a:solidFill>
-              </a:rPr>
-              <a:t>  – ImageNet LSVRC 2015 — 1位</a:t>
-            </a:r>
-          </a:p>
-          <a:p>
-            <a:pPr lvl="1">
-              <a:spcBef>
-                <a:spcPts val="200"/>
-              </a:spcBef>
-            </a:pPr>
-            <a:r>
-              <a:rPr sz="1600" b="0">
-                <a:solidFill>
-                  <a:srgbClr val="2D3748"/>
-                </a:solidFill>
-              </a:rPr>
-              <a:t>  – CIFAR-10 / COCO Object Detection</a:t>
-            </a:r>
-          </a:p>
-          <a:p>
-            <a:pPr>
-              <a:spcBef>
-                <a:spcPts val="600"/>
-              </a:spcBef>
-            </a:pPr>
-            <a:r>
-              <a:rPr sz="1900" b="1">
-                <a:solidFill>
-                  <a:srgbClr val="1A3A6C"/>
-                </a:solidFill>
-              </a:rPr>
-              <a:t>• まとめと影響</a:t>
+            <a:pPr indent="0" marL="0"/>
+            <a:r>
+              <a:rPr lang="ja-JP" altLang="en-US" sz="1800" b="1">
+                <a:solidFill>
+                  <a:srgbClr val="FFFFFF"/>
+                </a:solidFill>
+              </a:rPr>
+              <a:t>① 導入</a:t>
+            </a:r>
+          </a:p>
+          <a:p>
+            <a:pPr indent="0" marL="0"/>
+            <a:r>
+              <a:rPr lang="ja-JP" altLang="en-US" sz="1400">
+                <a:solidFill>
+                  <a:srgbClr val="CCCCCC"/>
+                </a:solidFill>
+              </a:rPr>
+              <a:t>　　研究背景 ／ 問題提起 ／ 解決のポイント</a:t>
+            </a:r>
+          </a:p>
+          <a:p>
+            <a:pPr indent="0" marL="0"/>
+            <a:r>
+              <a:rPr lang="ja-JP" altLang="en-US" sz="1800" b="1">
+                <a:solidFill>
+                  <a:srgbClr val="FFFFFF"/>
+                </a:solidFill>
+              </a:rPr>
+              <a:t>② 関連研究</a:t>
+            </a:r>
+          </a:p>
+          <a:p>
+            <a:pPr indent="0" marL="0"/>
+            <a:r>
+              <a:rPr lang="ja-JP" altLang="en-US" sz="1400">
+                <a:solidFill>
+                  <a:srgbClr val="CCCCCC"/>
+                </a:solidFill>
+              </a:rPr>
+              <a:t>　　残差に関する研究 ／ Shortcut接続の歴史 ／ ResNetとの違い</a:t>
+            </a:r>
+          </a:p>
+          <a:p>
+            <a:pPr indent="0" marL="0"/>
+            <a:r>
+              <a:rPr lang="ja-JP" altLang="en-US" sz="1800" b="1">
+                <a:solidFill>
+                  <a:srgbClr val="FFFFFF"/>
+                </a:solidFill>
+              </a:rPr>
+              <a:t>③ 開発手法</a:t>
+            </a:r>
+          </a:p>
+          <a:p>
+            <a:pPr indent="0" marL="0"/>
+            <a:r>
+              <a:rPr lang="ja-JP" altLang="en-US" sz="1400">
+                <a:solidFill>
+                  <a:srgbClr val="CCCCCC"/>
+                </a:solidFill>
+              </a:rPr>
+              <a:t>　　基本アイデア ／ スキップ接続 ／ ネットワーク構造</a:t>
+            </a:r>
+          </a:p>
+          <a:p>
+            <a:pPr indent="0" marL="0"/>
+            <a:r>
+              <a:rPr lang="ja-JP" altLang="en-US" sz="1800" b="1">
+                <a:solidFill>
+                  <a:srgbClr val="FFFFFF"/>
+                </a:solidFill>
+              </a:rPr>
+              <a:t>④ 実験</a:t>
+            </a:r>
+          </a:p>
+          <a:p>
+            <a:pPr indent="0" marL="0"/>
+            <a:r>
+              <a:rPr lang="ja-JP" altLang="en-US" sz="1400">
+                <a:solidFill>
+                  <a:srgbClr val="CCCCCC"/>
+                </a:solidFill>
+              </a:rPr>
+              <a:t>　　ImageNet分類 ／ CIFAR-10 ／ 物体検出</a:t>
+            </a:r>
+          </a:p>
+          <a:p>
+            <a:pPr indent="0" marL="0"/>
+            <a:r>
+              <a:rPr lang="ja-JP" altLang="en-US" sz="1800" b="1">
+                <a:solidFill>
+                  <a:srgbClr val="FFFFFF"/>
+                </a:solidFill>
+              </a:rPr>
+              <a:t>⑤ 結果 ／ おまけ</a:t>
             </a:r>
           </a:p>
         </p:txBody>

</xml_diff>